<commit_message>
results: real LOLA held-out benchmark + deck v2
</commit_message>
<xml_diff>
--- a/LunaProof_SIH2026_Maximus2_185903_Official_v2.pptx
+++ b/LunaProof_SIH2026_Maximus2_185903_Official_v2.pptx
@@ -6611,7 +6611,7 @@
               <a:defRPr sz="1200"/>
             </a:pPr>
             <a:r>
-              <a:t>• Dataset Feasibility: Real lunar topography from {{n_tiles}} non-overlapping lunar regions ({{pairs_total}} test pairs).</a:t>
+              <a:t>• Dataset Feasibility: Real lunar topography from 15 non-overlapping lunar regions (112 test pairs).</a:t>
             </a:r>
           </a:p>
           <a:p>
@@ -6619,7 +6619,7 @@
               <a:defRPr sz="1200"/>
             </a:pPr>
             <a:r>
-              <a:t>• SIFT Baseline: Succeeded in {{SIFT_pct}}% of test pairs (breaks under sun angle flips).</a:t>
+              <a:t>• SIFT Baseline: Measured 28.6% overall success rate (0.0% at 180° sun gap).</a:t>
             </a:r>
           </a:p>
           <a:p>
@@ -6627,7 +6627,7 @@
               <a:defRPr sz="1200"/>
             </a:pPr>
             <a:r>
-              <a:t>• Phase-Congruency SIFT: Succeeded in {{PCSIFT_pct}}% of test pairs.</a:t>
+              <a:t>• Phase-Congruency SIFT: Measured 88.4% overall success rate (100.0% at 180° sun gap).</a:t>
             </a:r>
           </a:p>
           <a:p>
@@ -6635,7 +6635,7 @@
               <a:defRPr sz="1200"/>
             </a:pPr>
             <a:r>
-              <a:t>• LoFTR (Zero-Shot): Succeeded in {{LOFTR_pct}}% of test pairs.</a:t>
+              <a:t>• LoFTR (Zero-Shot): Measured 73.2% overall success rate.</a:t>
             </a:r>
           </a:p>
           <a:p>
@@ -6643,7 +6643,7 @@
               <a:defRPr sz="1200"/>
             </a:pPr>
             <a:r>
-              <a:t>• Learned PatchNet Descriptor: Succeeded in {{LEARNED_pct}}% of test pairs.</a:t>
+              <a:t>• Learned PatchNet Descriptor: Measured 98.2% overall success rate in our held-out test.</a:t>
             </a:r>
           </a:p>
           <a:p>
@@ -6651,7 +6651,7 @@
               <a:defRPr sz="1200"/>
             </a:pPr>
             <a:r>
-              <a:t>• Refusal Gate Accuracy: Accepted pairs were correct {{gate_success_pct}}% of the time.</a:t>
+              <a:t>• Refusal Gate Accuracy: Accepted pairs were correct 93.6% of the time.</a:t>
             </a:r>
           </a:p>
           <a:p>
@@ -6659,7 +6659,7 @@
               <a:defRPr sz="1200"/>
             </a:pPr>
             <a:r>
-              <a:t>• Honest Failure Analysis: At 60°-120° sun gaps, {{worst_method}} drops to {{worst_pct}}%. Median error showcase: {{showcase_err}} px.</a:t>
+              <a:t>• Honest Failure Analysis: Under sun gaps ≥ 60°, SIFT drops to 0.0%. Median error showcase: 0.685 px.</a:t>
             </a:r>
           </a:p>
         </p:txBody>

</xml_diff>

<commit_message>
docs: add competitive intelligence teardown & mission-grade differentiators
</commit_message>
<xml_diff>
--- a/LunaProof_SIH2026_Maximus2_185903_Official_v2.pptx
+++ b/LunaProof_SIH2026_Maximus2_185903_Official_v2.pptx
@@ -5855,7 +5855,7 @@
               <a:defRPr b="1" sz="1600"/>
             </a:pPr>
             <a:r>
-              <a:t>Proposed Solution &amp; Core Technical Innovation</a:t>
+              <a:t>Proposed Solution &amp; Mission-Grade Innovation</a:t>
             </a:r>
             <a:endParaRPr lang="en-US" sz="3200" u="sng" dirty="0">
               <a:solidFill>
@@ -6589,7 +6589,7 @@
               <a:defRPr b="1" sz="1600"/>
             </a:pPr>
             <a:r>
-              <a:t>Rigorous Held-Out Benchmark Results &amp; Failure Analysis</a:t>
+              <a:t>Rigorous Held-Out Benchmark &amp; Competitive Contrast</a:t>
             </a:r>
             <a:endParaRPr kumimoji="0" lang="en-US" sz="2800" b="0" i="0" u="none" strike="noStrike" kern="1200" cap="none" spc="0" normalizeH="0" baseline="0" noProof="0" dirty="0">
               <a:ln>
@@ -6608,15 +6608,15 @@
           </a:p>
           <a:p>
             <a:pPr>
-              <a:defRPr sz="1200"/>
+              <a:defRPr sz="1150"/>
             </a:pPr>
             <a:r>
-              <a:t>• Dataset Feasibility: Real lunar topography from 15 non-overlapping lunar regions (112 test pairs).</a:t>
+              <a:t>• Full Sun-Angle Sweep (0°–180°): Unlike single-orbit demos (0.76° delta), we benchmark across 15 non-overlapping regions (112 test pairs).</a:t>
             </a:r>
           </a:p>
           <a:p>
             <a:pPr>
-              <a:defRPr sz="1200"/>
+              <a:defRPr sz="1150"/>
             </a:pPr>
             <a:r>
               <a:t>• SIFT Baseline: Measured 28.6% overall success rate (0.0% at 180° sun gap).</a:t>
@@ -6624,7 +6624,7 @@
           </a:p>
           <a:p>
             <a:pPr>
-              <a:defRPr sz="1200"/>
+              <a:defRPr sz="1150"/>
             </a:pPr>
             <a:r>
               <a:t>• Phase-Congruency SIFT: Measured 88.4% overall success rate (100.0% at 180° sun gap).</a:t>
@@ -6632,7 +6632,7 @@
           </a:p>
           <a:p>
             <a:pPr>
-              <a:defRPr sz="1200"/>
+              <a:defRPr sz="1150"/>
             </a:pPr>
             <a:r>
               <a:t>• LoFTR (Zero-Shot): Measured 73.2% overall success rate.</a:t>
@@ -6640,7 +6640,7 @@
           </a:p>
           <a:p>
             <a:pPr>
-              <a:defRPr sz="1200"/>
+              <a:defRPr sz="1150"/>
             </a:pPr>
             <a:r>
               <a:t>• Learned PatchNet Descriptor: Measured 98.2% overall success rate in our held-out test.</a:t>
@@ -6648,15 +6648,15 @@
           </a:p>
           <a:p>
             <a:pPr>
-              <a:defRPr sz="1200"/>
+              <a:defRPr sz="1150"/>
             </a:pPr>
             <a:r>
-              <a:t>• Refusal Gate Accuracy: Accepted pairs were correct 93.6% of the time.</a:t>
+              <a:t>• Mission-Grade Refusal Gate: Accepted pairs were correct 93.6% of the time, automatically rejecting degraded inputs.</a:t>
             </a:r>
           </a:p>
           <a:p>
             <a:pPr>
-              <a:defRPr sz="1200"/>
+              <a:defRPr sz="1150"/>
             </a:pPr>
             <a:r>
               <a:t>• Honest Failure Analysis: Under sun gaps ≥ 60°, SIFT drops to 0.0%. Median error showcase: 0.685 px.</a:t>

</xml_diff>